<commit_message>
fixes, version runs fully without errors
</commit_message>
<xml_diff>
--- a/data/presentation/tableaux_pres.pptx
+++ b/data/presentation/tableaux_pres.pptx
@@ -3504,7 +3504,7 @@
                           <a:ea typeface="Arial"/>
                           <a:sym typeface="Arial"/>
                         </a:rPr>
-                        <a:t>25</a:t>
+                        <a:t>29</a:t>
                       </a:r>
                     </a:p>
                   </a:txBody>
@@ -4045,6 +4045,122 @@
                   </a:tcPr>
                 </a:tc>
               </a:tr>
+              <a:tr h="377422">
+                <a:tc>
+                  <a:txBody>
+                    <a:bodyPr/>
+                    <a:lstStyle/>
+                    <a:p>
+                      <a:pPr algn="l" marL="50800" marR="50800">
+                        <a:lnSpc>
+                          <a:spcPct val="100000"/>
+                        </a:lnSpc>
+                        <a:spcBef>
+                          <a:spcPts val="400"/>
+                        </a:spcBef>
+                        <a:spcAft>
+                          <a:spcPts val="400"/>
+                        </a:spcAft>
+                        <a:buNone/>
+                      </a:pPr>
+                      <a:r>
+                        <a:rPr cap="none" sz="1600" i="0" b="0" u="none" strike="noStrike">
+                          <a:solidFill>
+                            <a:srgbClr val="000000">
+                              <a:alpha val="100000"/>
+                            </a:srgbClr>
+                          </a:solidFill>
+                          <a:latin typeface="Arial"/>
+                          <a:cs typeface="Arial"/>
+                          <a:ea typeface="Arial"/>
+                          <a:sym typeface="Arial"/>
+                        </a:rPr>
+                        <a:t>SGO</a:t>
+                      </a:r>
+                    </a:p>
+                  </a:txBody>
+                  <a:tcPr anchor="ctr" marB="50800" marT="50800" marR="0" marL="0">
+                    <a:lnL algn="ctr" cmpd="sng" cap="flat" w="0">
+                      <a:noFill/>
+                      <a:prstDash val="solid"/>
+                    </a:lnL>
+                    <a:lnR algn="ctr" cmpd="sng" cap="flat" w="0">
+                      <a:noFill/>
+                      <a:prstDash val="solid"/>
+                    </a:lnR>
+                    <a:lnT algn="ctr" cmpd="sng" cap="flat" w="0">
+                      <a:noFill/>
+                      <a:prstDash val="solid"/>
+                    </a:lnT>
+                    <a:lnB algn="ctr" cmpd="sng" cap="flat" w="0">
+                      <a:noFill/>
+                      <a:prstDash val="solid"/>
+                    </a:lnB>
+                    <a:solidFill>
+                      <a:srgbClr val="FFFFFF">
+                        <a:alpha val="0"/>
+                      </a:srgbClr>
+                    </a:solidFill>
+                  </a:tcPr>
+                </a:tc>
+                <a:tc>
+                  <a:txBody>
+                    <a:bodyPr/>
+                    <a:lstStyle/>
+                    <a:p>
+                      <a:pPr algn="ctr" marL="50800" marR="50800">
+                        <a:lnSpc>
+                          <a:spcPct val="100000"/>
+                        </a:lnSpc>
+                        <a:spcBef>
+                          <a:spcPts val="400"/>
+                        </a:spcBef>
+                        <a:spcAft>
+                          <a:spcPts val="400"/>
+                        </a:spcAft>
+                        <a:buNone/>
+                      </a:pPr>
+                      <a:r>
+                        <a:rPr cap="none" sz="1600" i="0" b="0" u="none" strike="noStrike">
+                          <a:solidFill>
+                            <a:srgbClr val="000000">
+                              <a:alpha val="100000"/>
+                            </a:srgbClr>
+                          </a:solidFill>
+                          <a:latin typeface="Arial"/>
+                          <a:cs typeface="Arial"/>
+                          <a:ea typeface="Arial"/>
+                          <a:sym typeface="Arial"/>
+                        </a:rPr>
+                        <a:t>12</a:t>
+                      </a:r>
+                    </a:p>
+                  </a:txBody>
+                  <a:tcPr anchor="ctr" marB="50800" marT="50800" marR="0" marL="0">
+                    <a:lnL algn="ctr" cmpd="sng" cap="flat" w="0">
+                      <a:noFill/>
+                      <a:prstDash val="solid"/>
+                    </a:lnL>
+                    <a:lnR algn="ctr" cmpd="sng" cap="flat" w="0">
+                      <a:noFill/>
+                      <a:prstDash val="solid"/>
+                    </a:lnR>
+                    <a:lnT algn="ctr" cmpd="sng" cap="flat" w="0">
+                      <a:noFill/>
+                      <a:prstDash val="solid"/>
+                    </a:lnT>
+                    <a:lnB algn="ctr" cmpd="sng" cap="flat" w="0">
+                      <a:noFill/>
+                      <a:prstDash val="solid"/>
+                    </a:lnB>
+                    <a:solidFill>
+                      <a:srgbClr val="FFFFFF">
+                        <a:alpha val="0"/>
+                      </a:srgbClr>
+                    </a:solidFill>
+                  </a:tcPr>
+                </a:tc>
+              </a:tr>
               <a:tr h="374743">
                 <a:tc>
                   <a:txBody>
@@ -4133,122 +4249,6 @@
                           <a:sym typeface="Arial"/>
                         </a:rPr>
                         <a:t>11</a:t>
-                      </a:r>
-                    </a:p>
-                  </a:txBody>
-                  <a:tcPr anchor="ctr" marB="50800" marT="50800" marR="0" marL="0">
-                    <a:lnL algn="ctr" cmpd="sng" cap="flat" w="0">
-                      <a:noFill/>
-                      <a:prstDash val="solid"/>
-                    </a:lnL>
-                    <a:lnR algn="ctr" cmpd="sng" cap="flat" w="0">
-                      <a:noFill/>
-                      <a:prstDash val="solid"/>
-                    </a:lnR>
-                    <a:lnT algn="ctr" cmpd="sng" cap="flat" w="0">
-                      <a:noFill/>
-                      <a:prstDash val="solid"/>
-                    </a:lnT>
-                    <a:lnB algn="ctr" cmpd="sng" cap="flat" w="0">
-                      <a:noFill/>
-                      <a:prstDash val="solid"/>
-                    </a:lnB>
-                    <a:solidFill>
-                      <a:srgbClr val="FFFFFF">
-                        <a:alpha val="0"/>
-                      </a:srgbClr>
-                    </a:solidFill>
-                  </a:tcPr>
-                </a:tc>
-              </a:tr>
-              <a:tr h="377422">
-                <a:tc>
-                  <a:txBody>
-                    <a:bodyPr/>
-                    <a:lstStyle/>
-                    <a:p>
-                      <a:pPr algn="l" marL="50800" marR="50800">
-                        <a:lnSpc>
-                          <a:spcPct val="100000"/>
-                        </a:lnSpc>
-                        <a:spcBef>
-                          <a:spcPts val="400"/>
-                        </a:spcBef>
-                        <a:spcAft>
-                          <a:spcPts val="400"/>
-                        </a:spcAft>
-                        <a:buNone/>
-                      </a:pPr>
-                      <a:r>
-                        <a:rPr cap="none" sz="1600" i="0" b="0" u="none" strike="noStrike">
-                          <a:solidFill>
-                            <a:srgbClr val="000000">
-                              <a:alpha val="100000"/>
-                            </a:srgbClr>
-                          </a:solidFill>
-                          <a:latin typeface="Arial"/>
-                          <a:cs typeface="Arial"/>
-                          <a:ea typeface="Arial"/>
-                          <a:sym typeface="Arial"/>
-                        </a:rPr>
-                        <a:t>SGO</a:t>
-                      </a:r>
-                    </a:p>
-                  </a:txBody>
-                  <a:tcPr anchor="ctr" marB="50800" marT="50800" marR="0" marL="0">
-                    <a:lnL algn="ctr" cmpd="sng" cap="flat" w="0">
-                      <a:noFill/>
-                      <a:prstDash val="solid"/>
-                    </a:lnL>
-                    <a:lnR algn="ctr" cmpd="sng" cap="flat" w="0">
-                      <a:noFill/>
-                      <a:prstDash val="solid"/>
-                    </a:lnR>
-                    <a:lnT algn="ctr" cmpd="sng" cap="flat" w="0">
-                      <a:noFill/>
-                      <a:prstDash val="solid"/>
-                    </a:lnT>
-                    <a:lnB algn="ctr" cmpd="sng" cap="flat" w="0">
-                      <a:noFill/>
-                      <a:prstDash val="solid"/>
-                    </a:lnB>
-                    <a:solidFill>
-                      <a:srgbClr val="FFFFFF">
-                        <a:alpha val="0"/>
-                      </a:srgbClr>
-                    </a:solidFill>
-                  </a:tcPr>
-                </a:tc>
-                <a:tc>
-                  <a:txBody>
-                    <a:bodyPr/>
-                    <a:lstStyle/>
-                    <a:p>
-                      <a:pPr algn="ctr" marL="50800" marR="50800">
-                        <a:lnSpc>
-                          <a:spcPct val="100000"/>
-                        </a:lnSpc>
-                        <a:spcBef>
-                          <a:spcPts val="400"/>
-                        </a:spcBef>
-                        <a:spcAft>
-                          <a:spcPts val="400"/>
-                        </a:spcAft>
-                        <a:buNone/>
-                      </a:pPr>
-                      <a:r>
-                        <a:rPr cap="none" sz="1600" i="0" b="0" u="none" strike="noStrike">
-                          <a:solidFill>
-                            <a:srgbClr val="000000">
-                              <a:alpha val="100000"/>
-                            </a:srgbClr>
-                          </a:solidFill>
-                          <a:latin typeface="Arial"/>
-                          <a:cs typeface="Arial"/>
-                          <a:ea typeface="Arial"/>
-                          <a:sym typeface="Arial"/>
-                        </a:rPr>
-                        <a:t>8</a:t>
                       </a:r>
                     </a:p>
                   </a:txBody>

</xml_diff>